<commit_message>
Add theme logo to sponsorship flyer, fix layout
</commit_message>
<xml_diff>
--- a/Blitz-and-Glitz_Sponsorship-Flyer.pptx
+++ b/Blitz-and-Glitz_Sponsorship-Flyer.pptx
@@ -875,36 +875,40 @@
           <a:chExt cx="0" cy="0"/>
         </a:xfrm>
       </p:grpSpPr>
-      <p:sp>
-        <p:nvSpPr>
-          <p:cNvPr id="2" name="Shape 0"/>
-          <p:cNvSpPr/>
-          <p:nvPr/>
-        </p:nvSpPr>
-        <p:spPr>
-          <a:xfrm>
-            <a:off x="365760" y="292608"/>
-            <a:ext cx="658368" cy="658368"/>
-          </a:xfrm>
-          <a:prstGeom prst="ellipse">
-            <a:avLst/>
-          </a:prstGeom>
-          <a:solidFill>
-            <a:srgbClr val="B36A73"/>
-          </a:solidFill>
-          <a:ln/>
-        </p:spPr>
-      </p:sp>
-      <p:sp>
-        <p:nvSpPr>
-          <p:cNvPr id="3" name="Text 1"/>
-          <p:cNvSpPr/>
-          <p:nvPr/>
-        </p:nvSpPr>
-        <p:spPr>
-          <a:xfrm>
-            <a:off x="365760" y="292608"/>
-            <a:ext cx="658368" cy="658368"/>
+      <p:pic>
+        <p:nvPicPr>
+          <p:cNvPr id="2" name="Image 0" descr="/tmp/build/logo.png">    </p:cNvPr>
+          <p:cNvPicPr>
+            <a:picLocks noChangeAspect="1"/>
+          </p:cNvPicPr>
+          <p:nvPr/>
+        </p:nvPicPr>
+        <p:blipFill>
+          <a:blip r:embed="rId1"/>
+          <a:stretch>
+            <a:fillRect/>
+          </a:stretch>
+        </p:blipFill>
+        <p:spPr>
+          <a:xfrm>
+            <a:off x="3602736" y="137160"/>
+            <a:ext cx="566928" cy="566928"/>
+          </a:xfrm>
+          <a:prstGeom prst="rect">
+            <a:avLst/>
+          </a:prstGeom>
+        </p:spPr>
+      </p:pic>
+      <p:sp>
+        <p:nvSpPr>
+          <p:cNvPr id="3" name="Text 0"/>
+          <p:cNvSpPr/>
+          <p:nvPr/>
+        </p:nvSpPr>
+        <p:spPr>
+          <a:xfrm>
+            <a:off x="365760" y="731520"/>
+            <a:ext cx="7040880" cy="310896"/>
           </a:xfrm>
           <a:prstGeom prst="rect">
             <a:avLst/>
@@ -920,18 +924,40 @@
               <a:buNone/>
             </a:pPr>
             <a:r>
-              <a:rPr lang="en-US" sz="950" i="1" dirty="0">
-                <a:solidFill>
-                  <a:srgbClr val="FFFFFF"/>
+              <a:rPr lang="en-US" sz="2200" b="1" dirty="0">
+                <a:solidFill>
+                  <a:srgbClr val="4A5A3D"/>
                 </a:solidFill>
                 <a:latin typeface="Cambria" pitchFamily="34" charset="0"/>
                 <a:ea typeface="Cambria" pitchFamily="34" charset="-122"/>
                 <a:cs typeface="Cambria" pitchFamily="34" charset="-120"/>
               </a:rPr>
-              <a:t>Blitz</a:t>
-            </a:r>
-            <a:endParaRPr lang="en-US" sz="950" dirty="0"/>
-          </a:p>
+              <a:t>Sponsorship Levels</a:t>
+            </a:r>
+            <a:endParaRPr lang="en-US" sz="2200" dirty="0"/>
+          </a:p>
+        </p:txBody>
+      </p:sp>
+      <p:sp>
+        <p:nvSpPr>
+          <p:cNvPr id="4" name="Text 1"/>
+          <p:cNvSpPr/>
+          <p:nvPr/>
+        </p:nvSpPr>
+        <p:spPr>
+          <a:xfrm>
+            <a:off x="365760" y="1060704"/>
+            <a:ext cx="7040880" cy="164592"/>
+          </a:xfrm>
+          <a:prstGeom prst="rect">
+            <a:avLst/>
+          </a:prstGeom>
+          <a:noFill/>
+          <a:ln/>
+        </p:spPr>
+        <p:txBody>
+          <a:bodyPr wrap="square" lIns="0" tIns="0" rIns="0" bIns="0" rtlCol="0" anchor="t"/>
+          <a:lstStyle/>
           <a:p>
             <a:pPr algn="ctr" indent="0" marL="0">
               <a:buNone/>
@@ -939,13 +965,13 @@
             <a:r>
               <a:rPr lang="en-US" sz="950" i="1" dirty="0">
                 <a:solidFill>
-                  <a:srgbClr val="FFFFFF"/>
-                </a:solidFill>
-                <a:latin typeface="Cambria" pitchFamily="34" charset="0"/>
-                <a:ea typeface="Cambria" pitchFamily="34" charset="-122"/>
-                <a:cs typeface="Cambria" pitchFamily="34" charset="-120"/>
-              </a:rPr>
-              <a:t>&amp; Glitz</a:t>
+                  <a:srgbClr val="8A9A7A"/>
+                </a:solidFill>
+                <a:latin typeface="Calibri" pitchFamily="34" charset="0"/>
+                <a:ea typeface="Calibri" pitchFamily="34" charset="-122"/>
+                <a:cs typeface="Calibri" pitchFamily="34" charset="-120"/>
+              </a:rPr>
+              <a:t>Blitz &amp; Glitz — A Community Ladies Night Out</a:t>
             </a:r>
             <a:endParaRPr lang="en-US" sz="950" dirty="0"/>
           </a:p>
@@ -953,53 +979,14 @@
       </p:sp>
       <p:sp>
         <p:nvSpPr>
-          <p:cNvPr id="4" name="Text 2"/>
-          <p:cNvSpPr/>
-          <p:nvPr/>
-        </p:nvSpPr>
-        <p:spPr>
-          <a:xfrm>
-            <a:off x="1188720" y="256032"/>
-            <a:ext cx="6217920" cy="502920"/>
-          </a:xfrm>
-          <a:prstGeom prst="rect">
-            <a:avLst/>
-          </a:prstGeom>
-          <a:noFill/>
-          <a:ln/>
-        </p:spPr>
-        <p:txBody>
-          <a:bodyPr wrap="square" lIns="0" tIns="0" rIns="0" bIns="0" rtlCol="0" anchor="ctr"/>
-          <a:lstStyle/>
-          <a:p>
-            <a:pPr indent="0" marL="0">
-              <a:buNone/>
-            </a:pPr>
-            <a:r>
-              <a:rPr lang="en-US" sz="3000" b="1" dirty="0">
-                <a:solidFill>
-                  <a:srgbClr val="4A5A3D"/>
-                </a:solidFill>
-                <a:latin typeface="Cambria" pitchFamily="34" charset="0"/>
-                <a:ea typeface="Cambria" pitchFamily="34" charset="-122"/>
-                <a:cs typeface="Cambria" pitchFamily="34" charset="-120"/>
-              </a:rPr>
-              <a:t>Sponsorship Levels</a:t>
-            </a:r>
-            <a:endParaRPr lang="en-US" sz="3000" dirty="0"/>
-          </a:p>
-        </p:txBody>
-      </p:sp>
-      <p:sp>
-        <p:nvSpPr>
-          <p:cNvPr id="5" name="Text 3"/>
-          <p:cNvSpPr/>
-          <p:nvPr/>
-        </p:nvSpPr>
-        <p:spPr>
-          <a:xfrm>
-            <a:off x="1188720" y="731520"/>
-            <a:ext cx="6217920" cy="274320"/>
+          <p:cNvPr id="5" name="Text 2"/>
+          <p:cNvSpPr/>
+          <p:nvPr/>
+        </p:nvSpPr>
+        <p:spPr>
+          <a:xfrm>
+            <a:off x="365760" y="1207008"/>
+            <a:ext cx="7040880" cy="164592"/>
           </a:xfrm>
           <a:prstGeom prst="rect">
             <a:avLst/>
@@ -1011,11 +998,11 @@
           <a:bodyPr wrap="square" lIns="0" tIns="0" rIns="0" bIns="0" rtlCol="0" anchor="t"/>
           <a:lstStyle/>
           <a:p>
-            <a:pPr indent="0" marL="0">
+            <a:pPr algn="ctr" indent="0" marL="0">
               <a:buNone/>
             </a:pPr>
             <a:r>
-              <a:rPr lang="en-US" sz="1000" i="1" dirty="0">
+              <a:rPr lang="en-US" sz="900" dirty="0">
                 <a:solidFill>
                   <a:srgbClr val="8A9A7A"/>
                 </a:solidFill>
@@ -1023,21 +1010,21 @@
                 <a:ea typeface="Calibri" pitchFamily="34" charset="-122"/>
                 <a:cs typeface="Calibri" pitchFamily="34" charset="-120"/>
               </a:rPr>
-              <a:t>Blitz &amp; Glitz — A Community Ladies Night Out  ·  Sunday, August 23, 2026  ·  One Preston, Gunter, TX</a:t>
-            </a:r>
-            <a:endParaRPr lang="en-US" sz="1000" dirty="0"/>
-          </a:p>
-        </p:txBody>
-      </p:sp>
-      <p:sp>
-        <p:nvSpPr>
-          <p:cNvPr id="6" name="Shape 4"/>
-          <p:cNvSpPr/>
-          <p:nvPr/>
-        </p:nvSpPr>
-        <p:spPr>
-          <a:xfrm>
-            <a:off x="365760" y="1170432"/>
+              <a:t>Sunday, August 23, 2026  ·  One Preston Event Center, 50 Whispering Winds Drive, Gunter, TX</a:t>
+            </a:r>
+            <a:endParaRPr lang="en-US" sz="900" dirty="0"/>
+          </a:p>
+        </p:txBody>
+      </p:sp>
+      <p:sp>
+        <p:nvSpPr>
+          <p:cNvPr id="6" name="Shape 3"/>
+          <p:cNvSpPr/>
+          <p:nvPr/>
+        </p:nvSpPr>
+        <p:spPr>
+          <a:xfrm>
+            <a:off x="365760" y="1417320"/>
             <a:ext cx="7040880" cy="1874520"/>
           </a:xfrm>
           <a:prstGeom prst="roundRect">
@@ -1060,13 +1047,13 @@
       </p:sp>
       <p:sp>
         <p:nvSpPr>
-          <p:cNvPr id="7" name="Text 5"/>
-          <p:cNvSpPr/>
-          <p:nvPr/>
-        </p:nvSpPr>
-        <p:spPr>
-          <a:xfrm>
-            <a:off x="548640" y="1280160"/>
+          <p:cNvPr id="7" name="Text 4"/>
+          <p:cNvSpPr/>
+          <p:nvPr/>
+        </p:nvSpPr>
+        <p:spPr>
+          <a:xfrm>
+            <a:off x="548640" y="1527048"/>
             <a:ext cx="1600200" cy="384048"/>
           </a:xfrm>
           <a:prstGeom prst="rect">
@@ -1099,13 +1086,13 @@
       </p:sp>
       <p:sp>
         <p:nvSpPr>
-          <p:cNvPr id="8" name="Text 6"/>
-          <p:cNvSpPr/>
-          <p:nvPr/>
-        </p:nvSpPr>
-        <p:spPr>
-          <a:xfrm>
-            <a:off x="548640" y="1673352"/>
+          <p:cNvPr id="8" name="Text 5"/>
+          <p:cNvSpPr/>
+          <p:nvPr/>
+        </p:nvSpPr>
+        <p:spPr>
+          <a:xfrm>
+            <a:off x="548640" y="1920240"/>
             <a:ext cx="1600200" cy="1280160"/>
           </a:xfrm>
           <a:prstGeom prst="rect">
@@ -1138,13 +1125,13 @@
       </p:sp>
       <p:sp>
         <p:nvSpPr>
-          <p:cNvPr id="9" name="Text 7"/>
-          <p:cNvSpPr/>
-          <p:nvPr/>
-        </p:nvSpPr>
-        <p:spPr>
-          <a:xfrm>
-            <a:off x="2286000" y="1298448"/>
+          <p:cNvPr id="9" name="Text 6"/>
+          <p:cNvSpPr/>
+          <p:nvPr/>
+        </p:nvSpPr>
+        <p:spPr>
+          <a:xfrm>
+            <a:off x="2286000" y="1545336"/>
             <a:ext cx="4937760" cy="274320"/>
           </a:xfrm>
           <a:prstGeom prst="rect">
@@ -1177,13 +1164,13 @@
       </p:sp>
       <p:sp>
         <p:nvSpPr>
-          <p:cNvPr id="10" name="Text 8"/>
-          <p:cNvSpPr/>
-          <p:nvPr/>
-        </p:nvSpPr>
-        <p:spPr>
-          <a:xfrm>
-            <a:off x="2286000" y="1591056"/>
+          <p:cNvPr id="10" name="Text 7"/>
+          <p:cNvSpPr/>
+          <p:nvPr/>
+        </p:nvSpPr>
+        <p:spPr>
+          <a:xfrm>
+            <a:off x="2286000" y="1837944"/>
             <a:ext cx="4937760" cy="1371600"/>
           </a:xfrm>
           <a:prstGeom prst="rect">
@@ -1391,13 +1378,13 @@
       </p:sp>
       <p:sp>
         <p:nvSpPr>
-          <p:cNvPr id="11" name="Shape 9"/>
-          <p:cNvSpPr/>
-          <p:nvPr/>
-        </p:nvSpPr>
-        <p:spPr>
-          <a:xfrm>
-            <a:off x="365760" y="3154680"/>
+          <p:cNvPr id="11" name="Shape 8"/>
+          <p:cNvSpPr/>
+          <p:nvPr/>
+        </p:nvSpPr>
+        <p:spPr>
+          <a:xfrm>
+            <a:off x="365760" y="3364992"/>
             <a:ext cx="7040880" cy="1554480"/>
           </a:xfrm>
           <a:prstGeom prst="roundRect">
@@ -1420,13 +1407,13 @@
       </p:sp>
       <p:sp>
         <p:nvSpPr>
-          <p:cNvPr id="12" name="Text 10"/>
-          <p:cNvSpPr/>
-          <p:nvPr/>
-        </p:nvSpPr>
-        <p:spPr>
-          <a:xfrm>
-            <a:off x="548640" y="3264408"/>
+          <p:cNvPr id="12" name="Text 9"/>
+          <p:cNvSpPr/>
+          <p:nvPr/>
+        </p:nvSpPr>
+        <p:spPr>
+          <a:xfrm>
+            <a:off x="548640" y="3474720"/>
             <a:ext cx="1600200" cy="384048"/>
           </a:xfrm>
           <a:prstGeom prst="rect">
@@ -1459,13 +1446,13 @@
       </p:sp>
       <p:sp>
         <p:nvSpPr>
-          <p:cNvPr id="13" name="Text 11"/>
-          <p:cNvSpPr/>
-          <p:nvPr/>
-        </p:nvSpPr>
-        <p:spPr>
-          <a:xfrm>
-            <a:off x="548640" y="3657600"/>
+          <p:cNvPr id="13" name="Text 10"/>
+          <p:cNvSpPr/>
+          <p:nvPr/>
+        </p:nvSpPr>
+        <p:spPr>
+          <a:xfrm>
+            <a:off x="548640" y="3867912"/>
             <a:ext cx="1600200" cy="960120"/>
           </a:xfrm>
           <a:prstGeom prst="rect">
@@ -1498,13 +1485,13 @@
       </p:sp>
       <p:sp>
         <p:nvSpPr>
-          <p:cNvPr id="14" name="Text 12"/>
-          <p:cNvSpPr/>
-          <p:nvPr/>
-        </p:nvSpPr>
-        <p:spPr>
-          <a:xfrm>
-            <a:off x="2286000" y="3282696"/>
+          <p:cNvPr id="14" name="Text 11"/>
+          <p:cNvSpPr/>
+          <p:nvPr/>
+        </p:nvSpPr>
+        <p:spPr>
+          <a:xfrm>
+            <a:off x="2286000" y="3493008"/>
             <a:ext cx="4937760" cy="274320"/>
           </a:xfrm>
           <a:prstGeom prst="rect">
@@ -1537,13 +1524,13 @@
       </p:sp>
       <p:sp>
         <p:nvSpPr>
-          <p:cNvPr id="15" name="Text 13"/>
-          <p:cNvSpPr/>
-          <p:nvPr/>
-        </p:nvSpPr>
-        <p:spPr>
-          <a:xfrm>
-            <a:off x="2286000" y="3575304"/>
+          <p:cNvPr id="15" name="Text 12"/>
+          <p:cNvSpPr/>
+          <p:nvPr/>
+        </p:nvSpPr>
+        <p:spPr>
+          <a:xfrm>
+            <a:off x="2286000" y="3785616"/>
             <a:ext cx="4937760" cy="1051560"/>
           </a:xfrm>
           <a:prstGeom prst="rect">
@@ -1679,13 +1666,13 @@
       </p:sp>
       <p:sp>
         <p:nvSpPr>
-          <p:cNvPr id="16" name="Shape 14"/>
-          <p:cNvSpPr/>
-          <p:nvPr/>
-        </p:nvSpPr>
-        <p:spPr>
-          <a:xfrm>
-            <a:off x="365760" y="4818888"/>
+          <p:cNvPr id="16" name="Shape 13"/>
+          <p:cNvSpPr/>
+          <p:nvPr/>
+        </p:nvSpPr>
+        <p:spPr>
+          <a:xfrm>
+            <a:off x="365760" y="4992624"/>
             <a:ext cx="7040880" cy="1554480"/>
           </a:xfrm>
           <a:prstGeom prst="roundRect">
@@ -1708,13 +1695,13 @@
       </p:sp>
       <p:sp>
         <p:nvSpPr>
-          <p:cNvPr id="17" name="Text 15"/>
-          <p:cNvSpPr/>
-          <p:nvPr/>
-        </p:nvSpPr>
-        <p:spPr>
-          <a:xfrm>
-            <a:off x="548640" y="4928616"/>
+          <p:cNvPr id="17" name="Text 14"/>
+          <p:cNvSpPr/>
+          <p:nvPr/>
+        </p:nvSpPr>
+        <p:spPr>
+          <a:xfrm>
+            <a:off x="548640" y="5102352"/>
             <a:ext cx="1600200" cy="384048"/>
           </a:xfrm>
           <a:prstGeom prst="rect">
@@ -1747,13 +1734,13 @@
       </p:sp>
       <p:sp>
         <p:nvSpPr>
-          <p:cNvPr id="18" name="Text 16"/>
-          <p:cNvSpPr/>
-          <p:nvPr/>
-        </p:nvSpPr>
-        <p:spPr>
-          <a:xfrm>
-            <a:off x="548640" y="5321808"/>
+          <p:cNvPr id="18" name="Text 15"/>
+          <p:cNvSpPr/>
+          <p:nvPr/>
+        </p:nvSpPr>
+        <p:spPr>
+          <a:xfrm>
+            <a:off x="548640" y="5495544"/>
             <a:ext cx="1600200" cy="960120"/>
           </a:xfrm>
           <a:prstGeom prst="rect">
@@ -1786,13 +1773,13 @@
       </p:sp>
       <p:sp>
         <p:nvSpPr>
-          <p:cNvPr id="19" name="Text 17"/>
-          <p:cNvSpPr/>
-          <p:nvPr/>
-        </p:nvSpPr>
-        <p:spPr>
-          <a:xfrm>
-            <a:off x="2286000" y="4946904"/>
+          <p:cNvPr id="19" name="Text 16"/>
+          <p:cNvSpPr/>
+          <p:nvPr/>
+        </p:nvSpPr>
+        <p:spPr>
+          <a:xfrm>
+            <a:off x="2286000" y="5120640"/>
             <a:ext cx="4937760" cy="274320"/>
           </a:xfrm>
           <a:prstGeom prst="rect">
@@ -1825,13 +1812,13 @@
       </p:sp>
       <p:sp>
         <p:nvSpPr>
-          <p:cNvPr id="20" name="Text 18"/>
-          <p:cNvSpPr/>
-          <p:nvPr/>
-        </p:nvSpPr>
-        <p:spPr>
-          <a:xfrm>
-            <a:off x="2286000" y="5239512"/>
+          <p:cNvPr id="20" name="Text 17"/>
+          <p:cNvSpPr/>
+          <p:nvPr/>
+        </p:nvSpPr>
+        <p:spPr>
+          <a:xfrm>
+            <a:off x="2286000" y="5413248"/>
             <a:ext cx="4937760" cy="1051560"/>
           </a:xfrm>
           <a:prstGeom prst="rect">
@@ -1967,13 +1954,13 @@
       </p:sp>
       <p:sp>
         <p:nvSpPr>
-          <p:cNvPr id="21" name="Shape 19"/>
-          <p:cNvSpPr/>
-          <p:nvPr/>
-        </p:nvSpPr>
-        <p:spPr>
-          <a:xfrm>
-            <a:off x="365760" y="6483096"/>
+          <p:cNvPr id="21" name="Shape 18"/>
+          <p:cNvSpPr/>
+          <p:nvPr/>
+        </p:nvSpPr>
+        <p:spPr>
+          <a:xfrm>
+            <a:off x="365760" y="6620256"/>
             <a:ext cx="7040880" cy="1325880"/>
           </a:xfrm>
           <a:prstGeom prst="roundRect">
@@ -1996,13 +1983,13 @@
       </p:sp>
       <p:sp>
         <p:nvSpPr>
-          <p:cNvPr id="22" name="Text 20"/>
-          <p:cNvSpPr/>
-          <p:nvPr/>
-        </p:nvSpPr>
-        <p:spPr>
-          <a:xfrm>
-            <a:off x="548640" y="6592824"/>
+          <p:cNvPr id="22" name="Text 19"/>
+          <p:cNvSpPr/>
+          <p:nvPr/>
+        </p:nvSpPr>
+        <p:spPr>
+          <a:xfrm>
+            <a:off x="548640" y="6729984"/>
             <a:ext cx="1600200" cy="384048"/>
           </a:xfrm>
           <a:prstGeom prst="rect">
@@ -2035,13 +2022,13 @@
       </p:sp>
       <p:sp>
         <p:nvSpPr>
-          <p:cNvPr id="23" name="Text 21"/>
-          <p:cNvSpPr/>
-          <p:nvPr/>
-        </p:nvSpPr>
-        <p:spPr>
-          <a:xfrm>
-            <a:off x="548640" y="6986016"/>
+          <p:cNvPr id="23" name="Text 20"/>
+          <p:cNvSpPr/>
+          <p:nvPr/>
+        </p:nvSpPr>
+        <p:spPr>
+          <a:xfrm>
+            <a:off x="548640" y="7123176"/>
             <a:ext cx="1600200" cy="731520"/>
           </a:xfrm>
           <a:prstGeom prst="rect">
@@ -2074,13 +2061,13 @@
       </p:sp>
       <p:sp>
         <p:nvSpPr>
-          <p:cNvPr id="24" name="Text 22"/>
-          <p:cNvSpPr/>
-          <p:nvPr/>
-        </p:nvSpPr>
-        <p:spPr>
-          <a:xfrm>
-            <a:off x="2286000" y="6611112"/>
+          <p:cNvPr id="24" name="Text 21"/>
+          <p:cNvSpPr/>
+          <p:nvPr/>
+        </p:nvSpPr>
+        <p:spPr>
+          <a:xfrm>
+            <a:off x="2286000" y="6748272"/>
             <a:ext cx="4937760" cy="274320"/>
           </a:xfrm>
           <a:prstGeom prst="rect">
@@ -2113,13 +2100,13 @@
       </p:sp>
       <p:sp>
         <p:nvSpPr>
-          <p:cNvPr id="25" name="Text 23"/>
-          <p:cNvSpPr/>
-          <p:nvPr/>
-        </p:nvSpPr>
-        <p:spPr>
-          <a:xfrm>
-            <a:off x="2286000" y="6903720"/>
+          <p:cNvPr id="25" name="Text 22"/>
+          <p:cNvSpPr/>
+          <p:nvPr/>
+        </p:nvSpPr>
+        <p:spPr>
+          <a:xfrm>
+            <a:off x="2286000" y="7040880"/>
             <a:ext cx="4937760" cy="822960"/>
           </a:xfrm>
           <a:prstGeom prst="rect">
@@ -2231,13 +2218,13 @@
       </p:sp>
       <p:sp>
         <p:nvSpPr>
-          <p:cNvPr id="26" name="Shape 24"/>
-          <p:cNvSpPr/>
-          <p:nvPr/>
-        </p:nvSpPr>
-        <p:spPr>
-          <a:xfrm>
-            <a:off x="365760" y="7918704"/>
+          <p:cNvPr id="26" name="Shape 23"/>
+          <p:cNvSpPr/>
+          <p:nvPr/>
+        </p:nvSpPr>
+        <p:spPr>
+          <a:xfrm>
+            <a:off x="365760" y="8019288"/>
             <a:ext cx="7040880" cy="1188720"/>
           </a:xfrm>
           <a:prstGeom prst="roundRect">
@@ -2260,13 +2247,13 @@
       </p:sp>
       <p:sp>
         <p:nvSpPr>
-          <p:cNvPr id="27" name="Text 25"/>
-          <p:cNvSpPr/>
-          <p:nvPr/>
-        </p:nvSpPr>
-        <p:spPr>
-          <a:xfrm>
-            <a:off x="548640" y="8028432"/>
+          <p:cNvPr id="27" name="Text 24"/>
+          <p:cNvSpPr/>
+          <p:nvPr/>
+        </p:nvSpPr>
+        <p:spPr>
+          <a:xfrm>
+            <a:off x="548640" y="8129016"/>
             <a:ext cx="1600200" cy="384048"/>
           </a:xfrm>
           <a:prstGeom prst="rect">
@@ -2299,13 +2286,13 @@
       </p:sp>
       <p:sp>
         <p:nvSpPr>
-          <p:cNvPr id="28" name="Text 26"/>
-          <p:cNvSpPr/>
-          <p:nvPr/>
-        </p:nvSpPr>
-        <p:spPr>
-          <a:xfrm>
-            <a:off x="548640" y="8421624"/>
+          <p:cNvPr id="28" name="Text 25"/>
+          <p:cNvSpPr/>
+          <p:nvPr/>
+        </p:nvSpPr>
+        <p:spPr>
+          <a:xfrm>
+            <a:off x="548640" y="8522208"/>
             <a:ext cx="1600200" cy="594360"/>
           </a:xfrm>
           <a:prstGeom prst="rect">
@@ -2338,13 +2325,13 @@
       </p:sp>
       <p:sp>
         <p:nvSpPr>
-          <p:cNvPr id="29" name="Text 27"/>
-          <p:cNvSpPr/>
-          <p:nvPr/>
-        </p:nvSpPr>
-        <p:spPr>
-          <a:xfrm>
-            <a:off x="2286000" y="8046720"/>
+          <p:cNvPr id="29" name="Text 26"/>
+          <p:cNvSpPr/>
+          <p:nvPr/>
+        </p:nvSpPr>
+        <p:spPr>
+          <a:xfrm>
+            <a:off x="2286000" y="8147304"/>
             <a:ext cx="4937760" cy="274320"/>
           </a:xfrm>
           <a:prstGeom prst="rect">
@@ -2377,13 +2364,13 @@
       </p:sp>
       <p:sp>
         <p:nvSpPr>
-          <p:cNvPr id="30" name="Text 28"/>
-          <p:cNvSpPr/>
-          <p:nvPr/>
-        </p:nvSpPr>
-        <p:spPr>
-          <a:xfrm>
-            <a:off x="2286000" y="8339328"/>
+          <p:cNvPr id="30" name="Text 27"/>
+          <p:cNvSpPr/>
+          <p:nvPr/>
+        </p:nvSpPr>
+        <p:spPr>
+          <a:xfrm>
+            <a:off x="2286000" y="8439912"/>
             <a:ext cx="4937760" cy="685800"/>
           </a:xfrm>
           <a:prstGeom prst="rect">
@@ -2471,13 +2458,13 @@
       </p:sp>
       <p:sp>
         <p:nvSpPr>
-          <p:cNvPr id="31" name="Text 29"/>
-          <p:cNvSpPr/>
-          <p:nvPr/>
-        </p:nvSpPr>
-        <p:spPr>
-          <a:xfrm>
-            <a:off x="365760" y="9290304"/>
+          <p:cNvPr id="31" name="Text 28"/>
+          <p:cNvSpPr/>
+          <p:nvPr/>
+        </p:nvSpPr>
+        <p:spPr>
+          <a:xfrm>
+            <a:off x="365760" y="9354312"/>
             <a:ext cx="7040880" cy="274320"/>
           </a:xfrm>
           <a:prstGeom prst="rect">
@@ -2510,13 +2497,13 @@
       </p:sp>
       <p:sp>
         <p:nvSpPr>
-          <p:cNvPr id="32" name="Text 30"/>
-          <p:cNvSpPr/>
-          <p:nvPr/>
-        </p:nvSpPr>
-        <p:spPr>
-          <a:xfrm>
-            <a:off x="365760" y="9546336"/>
+          <p:cNvPr id="32" name="Text 29"/>
+          <p:cNvSpPr/>
+          <p:nvPr/>
+        </p:nvSpPr>
+        <p:spPr>
+          <a:xfrm>
+            <a:off x="365760" y="9610344"/>
             <a:ext cx="7040880" cy="274320"/>
           </a:xfrm>
           <a:prstGeom prst="rect">

</xml_diff>

<commit_message>
Add clickable hyperlink to flyer CTA; add PNG export
</commit_message>
<xml_diff>
--- a/Blitz-and-Glitz_Sponsorship-Flyer.pptx
+++ b/Blitz-and-Glitz_Sponsorship-Flyer.pptx
@@ -2489,7 +2489,42 @@
                 <a:ea typeface="Calibri" pitchFamily="34" charset="-122"/>
                 <a:cs typeface="Calibri" pitchFamily="34" charset="-120"/>
               </a:rPr>
-              <a:t>Ready to sponsor? Visit blitz-and-glitz.netlify.app/sponsors to learn more and get started</a:t>
+              <a:t>Ready to sponsor? Visit </a:t>
+            </a:r>
+            <a:pPr algn="ctr" indent="0" marL="0">
+              <a:buNone/>
+            </a:pPr>
+            <a:r>
+              <a:rPr lang="en-US" sz="1150" b="1" u="sng" dirty="0">
+                <a:solidFill>
+                  <a:srgbClr val="829840"/>
+                </a:solidFill>
+                <a:latin typeface="Calibri" pitchFamily="34" charset="0"/>
+                <a:ea typeface="Calibri" pitchFamily="34" charset="-122"/>
+                <a:cs typeface="Calibri" pitchFamily="34" charset="-120"/>
+                <a:hlinkClick r:id="rId2" invalidUrl="" action="" tgtFrame="" tooltip="" history="1" highlightClick="0" endSnd="0">
+                  <a:extLst>
+                    <a:ext uri="{A12FA001-AC4F-418D-AE19-62706E023703}">
+                      <ahyp:hlinkClr xmlns:ahyp="http://schemas.microsoft.com/office/drawing/2018/hyperlinkcolor" val="tx"/>
+                    </a:ext>
+                  </a:extLst>
+                </a:hlinkClick>
+              </a:rPr>
+              <a:t>blitz-and-glitz.netlify.app/sponsors</a:t>
+            </a:r>
+            <a:pPr algn="ctr" indent="0" marL="0">
+              <a:buNone/>
+            </a:pPr>
+            <a:r>
+              <a:rPr lang="en-US" sz="1150" b="1" dirty="0">
+                <a:solidFill>
+                  <a:srgbClr val="4A5A3D"/>
+                </a:solidFill>
+                <a:latin typeface="Calibri" pitchFamily="34" charset="0"/>
+                <a:ea typeface="Calibri" pitchFamily="34" charset="-122"/>
+                <a:cs typeface="Calibri" pitchFamily="34" charset="-120"/>
+              </a:rPr>
+              <a:t> to learn more and get started</a:t>
             </a:r>
             <a:endParaRPr lang="en-US" sz="1150" dirty="0"/>
           </a:p>

</xml_diff>